<commit_message>
Update on looks and starting to add JavaScript slides.
</commit_message>
<xml_diff>
--- a/Slides/Chapter02.pptx
+++ b/Slides/Chapter02.pptx
@@ -152,6 +152,11 @@
       </a:defRPr>
     </a:lvl9pPr>
   </p:defaultTextStyle>
+  <p:extLst>
+    <p:ext uri="{EFAFB233-063F-42B5-8137-9DF3F51BA10A}">
+      <p15:sldGuideLst xmlns:p15="http://schemas.microsoft.com/office/powerpoint/2012/main"/>
+    </p:ext>
+  </p:extLst>
 </p:presentation>
 </file>
 
@@ -237,7 +242,7 @@
           <a:p>
             <a:fld id="{C594D6A2-E690-AE44-B31E-9BCFD0C67BA5}" type="datetimeFigureOut">
               <a:rPr lang="en-US" smtClean="0"/>
-              <a:t>11/20/25</a:t>
+              <a:t>8/27/26</a:t>
             </a:fld>
             <a:endParaRPr lang="en-US"/>
           </a:p>
@@ -1031,7 +1036,7 @@
           <a:p>
             <a:fld id="{624D9F20-0CDB-DC45-97C1-8E3888B449A2}" type="datetimeFigureOut">
               <a:rPr lang="en-US" smtClean="0"/>
-              <a:t>11/19/25</a:t>
+              <a:t>8/27/26</a:t>
             </a:fld>
             <a:endParaRPr lang="en-US"/>
           </a:p>
@@ -1239,7 +1244,7 @@
           <a:p>
             <a:fld id="{624D9F20-0CDB-DC45-97C1-8E3888B449A2}" type="datetimeFigureOut">
               <a:rPr lang="en-US" smtClean="0"/>
-              <a:t>11/19/25</a:t>
+              <a:t>8/27/26</a:t>
             </a:fld>
             <a:endParaRPr lang="en-US"/>
           </a:p>
@@ -1580,7 +1585,7 @@
             <a:fld id="{59E145AF-2465-1345-A673-F2664B07CED8}" type="datetime5">
               <a:rPr lang="en-US" smtClean="0"/>
               <a:pPr/>
-              <a:t>19-Nov-25</a:t>
+              <a:t>27-Aug-26</a:t>
             </a:fld>
             <a:endParaRPr lang="en-US" dirty="0"/>
           </a:p>
@@ -1866,7 +1871,7 @@
             <a:fld id="{59E145AF-2465-1345-A673-F2664B07CED8}" type="datetime5">
               <a:rPr lang="en-US" smtClean="0"/>
               <a:pPr/>
-              <a:t>19-Nov-25</a:t>
+              <a:t>27-Aug-26</a:t>
             </a:fld>
             <a:endParaRPr lang="en-US" dirty="0"/>
           </a:p>
@@ -2191,7 +2196,7 @@
             <a:fld id="{59E145AF-2465-1345-A673-F2664B07CED8}" type="datetime5">
               <a:rPr lang="en-US" smtClean="0"/>
               <a:pPr/>
-              <a:t>19-Nov-25</a:t>
+              <a:t>27-Aug-26</a:t>
             </a:fld>
             <a:endParaRPr lang="en-US" dirty="0"/>
           </a:p>
@@ -2589,7 +2594,7 @@
             <a:fld id="{59E145AF-2465-1345-A673-F2664B07CED8}" type="datetime5">
               <a:rPr lang="en-US" smtClean="0"/>
               <a:pPr/>
-              <a:t>19-Nov-25</a:t>
+              <a:t>27-Aug-26</a:t>
             </a:fld>
             <a:endParaRPr lang="en-US" dirty="0"/>
           </a:p>
@@ -2836,7 +2841,7 @@
             <a:fld id="{59E145AF-2465-1345-A673-F2664B07CED8}" type="datetime5">
               <a:rPr lang="en-US" smtClean="0"/>
               <a:pPr/>
-              <a:t>19-Nov-25</a:t>
+              <a:t>27-Aug-26</a:t>
             </a:fld>
             <a:endParaRPr lang="en-US" dirty="0"/>
           </a:p>
@@ -2977,7 +2982,7 @@
           <a:p>
             <a:fld id="{624D9F20-0CDB-DC45-97C1-8E3888B449A2}" type="datetimeFigureOut">
               <a:rPr lang="en-US" smtClean="0"/>
-              <a:t>11/19/25</a:t>
+              <a:t>8/27/26</a:t>
             </a:fld>
             <a:endParaRPr lang="en-US"/>
           </a:p>
@@ -3087,7 +3092,7 @@
           <a:p>
             <a:fld id="{624D9F20-0CDB-DC45-97C1-8E3888B449A2}" type="datetimeFigureOut">
               <a:rPr lang="en-US" smtClean="0"/>
-              <a:t>11/19/25</a:t>
+              <a:t>8/27/26</a:t>
             </a:fld>
             <a:endParaRPr lang="en-US"/>
           </a:p>
@@ -3536,7 +3541,7 @@
           <a:p>
             <a:fld id="{624D9F20-0CDB-DC45-97C1-8E3888B449A2}" type="datetimeFigureOut">
               <a:rPr lang="en-US" smtClean="0"/>
-              <a:t>11/19/25</a:t>
+              <a:t>8/27/26</a:t>
             </a:fld>
             <a:endParaRPr lang="en-US"/>
           </a:p>
@@ -7100,12 +7105,12 @@
           <a:p>
             <a:pPr lvl="1"/>
             <a:r>
-              <a:rPr lang="en-US" dirty="0" err="1"/>
-              <a:t>UInique</a:t>
-            </a:r>
-            <a:r>
-              <a:rPr lang="en-US" dirty="0"/>
-              <a:t> approach</a:t>
+              <a:rPr lang="en-US"/>
+              <a:t>Unique </a:t>
+            </a:r>
+            <a:r>
+              <a:rPr lang="en-US" dirty="0"/>
+              <a:t>approach</a:t>
             </a:r>
           </a:p>
           <a:p>

</xml_diff>